<commit_message>
docs: overhaul user manual for non-technical users with 12 UI screenshots and setup dedicated Panduan folder
</commit_message>
<xml_diff>
--- a/docs/Sosialisasi dan Panduan Penggunaan E-Learning UAY.pptx
+++ b/docs/Sosialisasi dan Panduan Penggunaan E-Learning UAY.pptx
@@ -9296,52 +9296,52 @@
               </a:defRPr>
             </a:pPr>
             <a:r>
-              <a:t>•  Terintegrasi dengan Keycloak SSO resmi UAY</a:t>
-            </a:r>
-          </a:p>
-          <a:p>
-            <a:pPr>
-              <a:spcAft>
-                <a:spcPts val="400"/>
-              </a:spcAft>
-              <a:defRPr sz="1100">
-                <a:solidFill>
-                  <a:srgbClr val="334155"/>
-                </a:solidFill>
-              </a:defRPr>
-            </a:pPr>
-            <a:r>
-              <a:t>•  Zero-Password lokal di e-learning</a:t>
-            </a:r>
-          </a:p>
-          <a:p>
-            <a:pPr>
-              <a:spcAft>
-                <a:spcPts val="400"/>
-              </a:spcAft>
-              <a:defRPr sz="1100">
-                <a:solidFill>
-                  <a:srgbClr val="334155"/>
-                </a:solidFill>
-              </a:defRPr>
-            </a:pPr>
-            <a:r>
-              <a:t>•  Dukungan MFA / 2FA untuk pimpinan dan dosen</a:t>
-            </a:r>
-          </a:p>
-          <a:p>
-            <a:pPr>
-              <a:spcAft>
-                <a:spcPts val="400"/>
-              </a:spcAft>
-              <a:defRPr sz="1100">
-                <a:solidFill>
-                  <a:srgbClr val="334155"/>
-                </a:solidFill>
-              </a:defRPr>
-            </a:pPr>
-            <a:r>
-              <a:t>•  Keamanan akun terjamin dan tersinkronisasi</a:t>
+              <a:t>•  Terintegrasi dengan Akun Resmi Kampus (SSO UAY)</a:t>
+            </a:r>
+          </a:p>
+          <a:p>
+            <a:pPr>
+              <a:spcAft>
+                <a:spcPts val="400"/>
+              </a:spcAft>
+              <a:defRPr sz="1100">
+                <a:solidFill>
+                  <a:srgbClr val="334155"/>
+                </a:solidFill>
+              </a:defRPr>
+            </a:pPr>
+            <a:r>
+              <a:t>•  Satu akun terpadu untuk seluruh layanan kampus</a:t>
+            </a:r>
+          </a:p>
+          <a:p>
+            <a:pPr>
+              <a:spcAft>
+                <a:spcPts val="400"/>
+              </a:spcAft>
+              <a:defRPr sz="1100">
+                <a:solidFill>
+                  <a:srgbClr val="334155"/>
+                </a:solidFill>
+              </a:defRPr>
+            </a:pPr>
+            <a:r>
+              <a:t>•  Dukungan verifikasi dua faktor (MFA/2FA)</a:t>
+            </a:r>
+          </a:p>
+          <a:p>
+            <a:pPr>
+              <a:spcAft>
+                <a:spcPts val="400"/>
+              </a:spcAft>
+              <a:defRPr sz="1100">
+                <a:solidFill>
+                  <a:srgbClr val="334155"/>
+                </a:solidFill>
+              </a:defRPr>
+            </a:pPr>
+            <a:r>
+              <a:t>•  Keamanan akun terlindungi dan tersinkronisasi</a:t>
             </a:r>
           </a:p>
         </p:txBody>
@@ -12786,7 +12786,7 @@
               </a:defRPr>
             </a:pPr>
             <a:r>
-              <a:t>IDENTITY GATEWAY</a:t>
+              <a:t>SATU PINTU AKSES</a:t>
             </a:r>
           </a:p>
           <a:p>
@@ -12801,67 +12801,67 @@
               </a:defRPr>
             </a:pPr>
             <a:r>
-              <a:t>1. SSO Keycloak</a:t>
-            </a:r>
-          </a:p>
-          <a:p>
-            <a:pPr>
-              <a:spcAft>
-                <a:spcPts val="400"/>
-              </a:spcAft>
-              <a:defRPr sz="1100">
-                <a:solidFill>
-                  <a:srgbClr val="334155"/>
-                </a:solidFill>
-              </a:defRPr>
-            </a:pPr>
-            <a:r>
-              <a:t>•  Gerbang identitas resmi kampus</a:t>
-            </a:r>
-          </a:p>
-          <a:p>
-            <a:pPr>
-              <a:spcAft>
-                <a:spcPts val="400"/>
-              </a:spcAft>
-              <a:defRPr sz="1100">
-                <a:solidFill>
-                  <a:srgbClr val="334155"/>
-                </a:solidFill>
-              </a:defRPr>
-            </a:pPr>
-            <a:r>
-              <a:t>•  Autentikasi akun mahasiswa &amp; staf</a:t>
-            </a:r>
-          </a:p>
-          <a:p>
-            <a:pPr>
-              <a:spcAft>
-                <a:spcPts val="400"/>
-              </a:spcAft>
-              <a:defRPr sz="1100">
-                <a:solidFill>
-                  <a:srgbClr val="334155"/>
-                </a:solidFill>
-              </a:defRPr>
-            </a:pPr>
-            <a:r>
-              <a:t>•  Penetapan peran &amp; token JWT</a:t>
-            </a:r>
-          </a:p>
-          <a:p>
-            <a:pPr>
-              <a:spcAft>
-                <a:spcPts val="400"/>
-              </a:spcAft>
-              <a:defRPr sz="1100">
-                <a:solidFill>
-                  <a:srgbClr val="334155"/>
-                </a:solidFill>
-              </a:defRPr>
-            </a:pPr>
-            <a:r>
-              <a:t>•  Single Sign-Out terpusat</a:t>
+              <a:t>1. Akun Kampus Terpadu</a:t>
+            </a:r>
+          </a:p>
+          <a:p>
+            <a:pPr>
+              <a:spcAft>
+                <a:spcPts val="400"/>
+              </a:spcAft>
+              <a:defRPr sz="1100">
+                <a:solidFill>
+                  <a:srgbClr val="334155"/>
+                </a:solidFill>
+              </a:defRPr>
+            </a:pPr>
+            <a:r>
+              <a:t>•  Gerbang masuk resmi universitas</a:t>
+            </a:r>
+          </a:p>
+          <a:p>
+            <a:pPr>
+              <a:spcAft>
+                <a:spcPts val="400"/>
+              </a:spcAft>
+              <a:defRPr sz="1100">
+                <a:solidFill>
+                  <a:srgbClr val="334155"/>
+                </a:solidFill>
+              </a:defRPr>
+            </a:pPr>
+            <a:r>
+              <a:t>•  Masuk menggunakan NIM atau Email UAY</a:t>
+            </a:r>
+          </a:p>
+          <a:p>
+            <a:pPr>
+              <a:spcAft>
+                <a:spcPts val="400"/>
+              </a:spcAft>
+              <a:defRPr sz="1100">
+                <a:solidFill>
+                  <a:srgbClr val="334155"/>
+                </a:solidFill>
+              </a:defRPr>
+            </a:pPr>
+            <a:r>
+              <a:t>•  Pengenalan peran Mahasiswa &amp; Dosen otomatis</a:t>
+            </a:r>
+          </a:p>
+          <a:p>
+            <a:pPr>
+              <a:spcAft>
+                <a:spcPts val="400"/>
+              </a:spcAft>
+              <a:defRPr sz="1100">
+                <a:solidFill>
+                  <a:srgbClr val="334155"/>
+                </a:solidFill>
+              </a:defRPr>
+            </a:pPr>
+            <a:r>
+              <a:t>•  Keluar aman terpadu (Logout)</a:t>
             </a:r>
           </a:p>
         </p:txBody>
@@ -14388,7 +14388,7 @@
               </a:defRPr>
             </a:pPr>
             <a:r>
-              <a:t>GERBANG MASUK SSO</a:t>
+              <a:t>GERBANG MASUK AKUN KAMPUS</a:t>
             </a:r>
           </a:p>
         </p:txBody>
@@ -14546,7 +14546,7 @@
               </a:defRPr>
             </a:pPr>
             <a:r>
-              <a:t>ALUR LOGIN</a:t>
+              <a:t>ALUR MASUK</a:t>
             </a:r>
           </a:p>
           <a:p>
@@ -14576,97 +14576,97 @@
               </a:defRPr>
             </a:pPr>
             <a:r>
-              <a:t>•  1. Buka situs elearning.uay.ac.id</a:t>
-            </a:r>
-          </a:p>
-          <a:p>
-            <a:pPr>
-              <a:spcAft>
-                <a:spcPts val="400"/>
-              </a:spcAft>
-              <a:defRPr sz="1100">
-                <a:solidFill>
-                  <a:srgbClr val="334155"/>
-                </a:solidFill>
-              </a:defRPr>
-            </a:pPr>
-            <a:r>
-              <a:t>•  2. Klik tombol utama 'Masuk dengan SSO UAY'</a:t>
-            </a:r>
-          </a:p>
-          <a:p>
-            <a:pPr>
-              <a:spcAft>
-                <a:spcPts val="400"/>
-              </a:spcAft>
-              <a:defRPr sz="1100">
-                <a:solidFill>
-                  <a:srgbClr val="334155"/>
-                </a:solidFill>
-              </a:defRPr>
-            </a:pPr>
-            <a:r>
-              <a:t>•  3. Masukkan Email Kampus Resmi / NIM / NIDN</a:t>
-            </a:r>
-          </a:p>
-          <a:p>
-            <a:pPr>
-              <a:spcAft>
-                <a:spcPts val="400"/>
-              </a:spcAft>
-              <a:defRPr sz="1100">
-                <a:solidFill>
-                  <a:srgbClr val="334155"/>
-                </a:solidFill>
-              </a:defRPr>
-            </a:pPr>
-            <a:r>
-              <a:t>•  4. Masukkan Kata Sandi SSO Anda</a:t>
-            </a:r>
-          </a:p>
-          <a:p>
-            <a:pPr>
-              <a:spcAft>
-                <a:spcPts val="400"/>
-              </a:spcAft>
-              <a:defRPr sz="1100">
-                <a:solidFill>
-                  <a:srgbClr val="334155"/>
-                </a:solidFill>
-              </a:defRPr>
-            </a:pPr>
-            <a:r>
-              <a:t>•  5. Jika MFA aktif: input 6 digit TOTP aplikasi</a:t>
-            </a:r>
-          </a:p>
-          <a:p>
-            <a:pPr>
-              <a:spcAft>
-                <a:spcPts val="400"/>
-              </a:spcAft>
-              <a:defRPr sz="1100">
-                <a:solidFill>
-                  <a:srgbClr val="334155"/>
-                </a:solidFill>
-              </a:defRPr>
-            </a:pPr>
-            <a:r>
-              <a:t>•  6. Sistem otomatis mengarahkan ke Dashboard Anda</a:t>
-            </a:r>
-          </a:p>
-          <a:p>
-            <a:pPr>
-              <a:spcAft>
-                <a:spcPts val="400"/>
-              </a:spcAft>
-              <a:defRPr sz="1100">
-                <a:solidFill>
-                  <a:srgbClr val="334155"/>
-                </a:solidFill>
-              </a:defRPr>
-            </a:pPr>
-            <a:r>
-              <a:t>•  Catatan: Kata sandi TIDAK disimpan di server e-learning</a:t>
+              <a:t>•  1. Buka situs https://e-learning.uay.ac.id</a:t>
+            </a:r>
+          </a:p>
+          <a:p>
+            <a:pPr>
+              <a:spcAft>
+                <a:spcPts val="400"/>
+              </a:spcAft>
+              <a:defRPr sz="1100">
+                <a:solidFill>
+                  <a:srgbClr val="334155"/>
+                </a:solidFill>
+              </a:defRPr>
+            </a:pPr>
+            <a:r>
+              <a:t>•  2. Klik tombol utama 'Masuk dengan Akun Kampus (SSO UAY)'</a:t>
+            </a:r>
+          </a:p>
+          <a:p>
+            <a:pPr>
+              <a:spcAft>
+                <a:spcPts val="400"/>
+              </a:spcAft>
+              <a:defRPr sz="1100">
+                <a:solidFill>
+                  <a:srgbClr val="334155"/>
+                </a:solidFill>
+              </a:defRPr>
+            </a:pPr>
+            <a:r>
+              <a:t>•  3. Masukkan Email Kampus Resmi / NIM Anda</a:t>
+            </a:r>
+          </a:p>
+          <a:p>
+            <a:pPr>
+              <a:spcAft>
+                <a:spcPts val="400"/>
+              </a:spcAft>
+              <a:defRPr sz="1100">
+                <a:solidFill>
+                  <a:srgbClr val="334155"/>
+                </a:solidFill>
+              </a:defRPr>
+            </a:pPr>
+            <a:r>
+              <a:t>•  4. Masukkan Kata Sandi akun kampus Anda</a:t>
+            </a:r>
+          </a:p>
+          <a:p>
+            <a:pPr>
+              <a:spcAft>
+                <a:spcPts val="400"/>
+              </a:spcAft>
+              <a:defRPr sz="1100">
+                <a:solidFill>
+                  <a:srgbClr val="334155"/>
+                </a:solidFill>
+              </a:defRPr>
+            </a:pPr>
+            <a:r>
+              <a:t>•  5. Jika diminta: masukkan kode verifikasi SMS/Aplikasi</a:t>
+            </a:r>
+          </a:p>
+          <a:p>
+            <a:pPr>
+              <a:spcAft>
+                <a:spcPts val="400"/>
+              </a:spcAft>
+              <a:defRPr sz="1100">
+                <a:solidFill>
+                  <a:srgbClr val="334155"/>
+                </a:solidFill>
+              </a:defRPr>
+            </a:pPr>
+            <a:r>
+              <a:t>•  6. Sistem otomatis mengenali peran Anda dan membuka beranda</a:t>
+            </a:r>
+          </a:p>
+          <a:p>
+            <a:pPr>
+              <a:spcAft>
+                <a:spcPts val="400"/>
+              </a:spcAft>
+              <a:defRPr sz="1100">
+                <a:solidFill>
+                  <a:srgbClr val="334155"/>
+                </a:solidFill>
+              </a:defRPr>
+            </a:pPr>
+            <a:r>
+              <a:t>•  Catatan: Cukup satu akun kampus untuk seluruh layanan UAY</a:t>
             </a:r>
           </a:p>
         </p:txBody>
@@ -14819,67 +14819,67 @@
               </a:defRPr>
             </a:pPr>
             <a:r>
-              <a:t>•  Zero Local Password: Akun terpusat di server kampus</a:t>
-            </a:r>
-          </a:p>
-          <a:p>
-            <a:pPr>
-              <a:spcAft>
-                <a:spcPts val="400"/>
-              </a:spcAft>
-              <a:defRPr sz="1100">
-                <a:solidFill>
-                  <a:srgbClr val="334155"/>
-                </a:solidFill>
-              </a:defRPr>
-            </a:pPr>
-            <a:r>
-              <a:t>•  Logout Bersih: Selalu klik 'Keluar' pada komputer lab</a:t>
-            </a:r>
-          </a:p>
-          <a:p>
-            <a:pPr>
-              <a:spcAft>
-                <a:spcPts val="400"/>
-              </a:spcAft>
-              <a:defRPr sz="1100">
-                <a:solidFill>
-                  <a:srgbClr val="334155"/>
-                </a:solidFill>
-              </a:defRPr>
-            </a:pPr>
-            <a:r>
-              <a:t>•  Reset Kata Sandi: Dilakukan melalui sso.uay.ac.id</a:t>
-            </a:r>
-          </a:p>
-          <a:p>
-            <a:pPr>
-              <a:spcAft>
-                <a:spcPts val="400"/>
-              </a:spcAft>
-              <a:defRPr sz="1100">
-                <a:solidFill>
-                  <a:srgbClr val="334155"/>
-                </a:solidFill>
-              </a:defRPr>
-            </a:pPr>
-            <a:r>
-              <a:t>•  Session Guard: Sesi otomatis diperpanjang saat aktif</a:t>
-            </a:r>
-          </a:p>
-          <a:p>
-            <a:pPr>
-              <a:spcAft>
-                <a:spcPts val="400"/>
-              </a:spcAft>
-              <a:defRPr sz="1100">
-                <a:solidFill>
-                  <a:srgbClr val="334155"/>
-                </a:solidFill>
-              </a:defRPr>
-            </a:pPr>
-            <a:r>
-              <a:t>•  Audit Log: Setiap upaya login terekam untuk audit keamanan</a:t>
+              <a:t>•  Satu Akun Kampus: Terhubung langsung data induk universitas</a:t>
+            </a:r>
+          </a:p>
+          <a:p>
+            <a:pPr>
+              <a:spcAft>
+                <a:spcPts val="400"/>
+              </a:spcAft>
+              <a:defRPr sz="1100">
+                <a:solidFill>
+                  <a:srgbClr val="334155"/>
+                </a:solidFill>
+              </a:defRPr>
+            </a:pPr>
+            <a:r>
+              <a:t>•  Keluar Bersih (Logout): Selalu klik 'Keluar' pada komputer lab</a:t>
+            </a:r>
+          </a:p>
+          <a:p>
+            <a:pPr>
+              <a:spcAft>
+                <a:spcPts val="400"/>
+              </a:spcAft>
+              <a:defRPr sz="1100">
+                <a:solidFill>
+                  <a:srgbClr val="334155"/>
+                </a:solidFill>
+              </a:defRPr>
+            </a:pPr>
+            <a:r>
+              <a:t>•  Reset Kata Sandi: Klik 'Lupa Kata Sandi' atau hubungi TIK</a:t>
+            </a:r>
+          </a:p>
+          <a:p>
+            <a:pPr>
+              <a:spcAft>
+                <a:spcPts val="400"/>
+              </a:spcAft>
+              <a:defRPr sz="1100">
+                <a:solidFill>
+                  <a:srgbClr val="334155"/>
+                </a:solidFill>
+              </a:defRPr>
+            </a:pPr>
+            <a:r>
+              <a:t>•  Kenyamanan Sesi: Sesi tetap aktif selama Anda beraktivitas</a:t>
+            </a:r>
+          </a:p>
+          <a:p>
+            <a:pPr>
+              <a:spcAft>
+                <a:spcPts val="400"/>
+              </a:spcAft>
+              <a:defRPr sz="1100">
+                <a:solidFill>
+                  <a:srgbClr val="334155"/>
+                </a:solidFill>
+              </a:defRPr>
+            </a:pPr>
+            <a:r>
+              <a:t>•  Keamanan Berlapis: Aktivitas perkuliahan tercatat akuntabel</a:t>
             </a:r>
           </a:p>
         </p:txBody>
@@ -16163,7 +16163,7 @@
               </a:defRPr>
             </a:pPr>
             <a:r>
-              <a:t>Jalur Telemetri Eksekutif untuk Pimpinan UAY</a:t>
+              <a:t>Pemantauan Eksekutif untuk Pimpinan UAY</a:t>
             </a:r>
           </a:p>
         </p:txBody>
@@ -16286,7 +16286,7 @@
               </a:defRPr>
             </a:pPr>
             <a:r>
-              <a:t>TEKNIS BRIDGING</a:t>
+              <a:t>PEMANTAUAN PIMPINAN</a:t>
             </a:r>
           </a:p>
           <a:p>
@@ -16301,67 +16301,67 @@
               </a:defRPr>
             </a:pPr>
             <a:r>
-              <a:t>Mekanisme Bridging Data</a:t>
-            </a:r>
-          </a:p>
-          <a:p>
-            <a:pPr>
-              <a:spcAft>
-                <a:spcPts val="400"/>
-              </a:spcAft>
-              <a:defRPr sz="1100">
-                <a:solidFill>
-                  <a:srgbClr val="334155"/>
-                </a:solidFill>
-              </a:defRPr>
-            </a:pPr>
-            <a:r>
-              <a:t>•  Endpoint aman: GET /api/v1/integrations/rector/snapshot</a:t>
-            </a:r>
-          </a:p>
-          <a:p>
-            <a:pPr>
-              <a:spcAft>
-                <a:spcPts val="400"/>
-              </a:spcAft>
-              <a:defRPr sz="1100">
-                <a:solidFill>
-                  <a:srgbClr val="334155"/>
-                </a:solidFill>
-              </a:defRPr>
-            </a:pPr>
-            <a:r>
-              <a:t>•  Otorisasi: Bearer Token RECTOR_INTEGRATION_TOKEN</a:t>
-            </a:r>
-          </a:p>
-          <a:p>
-            <a:pPr>
-              <a:spcAft>
-                <a:spcPts val="400"/>
-              </a:spcAft>
-              <a:defRPr sz="1100">
-                <a:solidFill>
-                  <a:srgbClr val="334155"/>
-                </a:solidFill>
-              </a:defRPr>
-            </a:pPr>
-            <a:r>
-              <a:t>•  Agregasi data tanpa membuka privasi konten kelas</a:t>
-            </a:r>
-          </a:p>
-          <a:p>
-            <a:pPr>
-              <a:spcAft>
-                <a:spcPts val="400"/>
-              </a:spcAft>
-              <a:defRPr sz="1100">
-                <a:solidFill>
-                  <a:srgbClr val="334155"/>
-                </a:solidFill>
-              </a:defRPr>
-            </a:pPr>
-            <a:r>
-              <a:t>•  Penyegaran data real-time berkala</a:t>
+              <a:t>Konektivitas Pemantauan Kampus</a:t>
+            </a:r>
+          </a:p>
+          <a:p>
+            <a:pPr>
+              <a:spcAft>
+                <a:spcPts val="400"/>
+              </a:spcAft>
+              <a:defRPr sz="1100">
+                <a:solidFill>
+                  <a:srgbClr val="334155"/>
+                </a:solidFill>
+              </a:defRPr>
+            </a:pPr>
+            <a:r>
+              <a:t>•  Sinkronisasi otomatis ke Dashboard Rektor UAY</a:t>
+            </a:r>
+          </a:p>
+          <a:p>
+            <a:pPr>
+              <a:spcAft>
+                <a:spcPts val="400"/>
+              </a:spcAft>
+              <a:defRPr sz="1100">
+                <a:solidFill>
+                  <a:srgbClr val="334155"/>
+                </a:solidFill>
+              </a:defRPr>
+            </a:pPr>
+            <a:r>
+              <a:t>•  Akses terlindungi khusus pimpinan universitas</a:t>
+            </a:r>
+          </a:p>
+          <a:p>
+            <a:pPr>
+              <a:spcAft>
+                <a:spcPts val="400"/>
+              </a:spcAft>
+              <a:defRPr sz="1100">
+                <a:solidFill>
+                  <a:srgbClr val="334155"/>
+                </a:solidFill>
+              </a:defRPr>
+            </a:pPr>
+            <a:r>
+              <a:t>•  Menyajikan ringkasan tanpa mengganggu perkuliahan</a:t>
+            </a:r>
+          </a:p>
+          <a:p>
+            <a:pPr>
+              <a:spcAft>
+                <a:spcPts val="400"/>
+              </a:spcAft>
+              <a:defRPr sz="1100">
+                <a:solidFill>
+                  <a:srgbClr val="334155"/>
+                </a:solidFill>
+              </a:defRPr>
+            </a:pPr>
+            <a:r>
+              <a:t>•  Pembaruan data keaktifan kuliah secara waktu nyata</a:t>
             </a:r>
           </a:p>
           <a:p>
@@ -16499,7 +16499,7 @@
               </a:defRPr>
             </a:pPr>
             <a:r>
-              <a:t>DATA TELEMETRI</a:t>
+              <a:t>RINGKASAN EKSEKUTIF</a:t>
             </a:r>
           </a:p>
           <a:p>
@@ -16544,7 +16544,7 @@
               </a:defRPr>
             </a:pPr>
             <a:r>
-              <a:t>•  • Total materi digital terbit (PDF, Slide, Video)</a:t>
+              <a:t>•  • Total materi kuliah terbit (PDF, Slide, Video)</a:t>
             </a:r>
           </a:p>
           <a:p>

</xml_diff>